<commit_message>
Subo las presentaciones fixeadas
</commit_message>
<xml_diff>
--- a/entrega_final/defensa/Presentacion_SocioUnido.pptx
+++ b/entrega_final/defensa/Presentacion_SocioUnido.pptx
@@ -4528,7 +4528,7 @@
         </p:nvSpPr>
         <p:spPr>
           <a:xfrm>
-            <a:off x="492842" y="288666"/>
+            <a:off x="492842" y="571499"/>
             <a:ext cx="11601450" cy="565668"/>
           </a:xfrm>
           <a:prstGeom prst="rect">
@@ -4594,10 +4594,10 @@
       </p:sp>
       <p:pic>
         <p:nvPicPr>
-          <p:cNvPr id="19" name="Imagen 18">
+          <p:cNvPr id="13" name="Imagen 12">
             <a:extLst>
               <a:ext uri="{FF2B5EF4-FFF2-40B4-BE49-F238E27FC236}">
-                <a16:creationId xmlns:a16="http://schemas.microsoft.com/office/drawing/2014/main" id="{3C5B3DFA-10CD-2833-AC8C-8BBF55432AB4}"/>
+                <a16:creationId xmlns:a16="http://schemas.microsoft.com/office/drawing/2014/main" id="{1AF19114-C1E0-706F-B04F-81B47D578E17}"/>
               </a:ext>
             </a:extLst>
           </p:cNvPr>
@@ -4608,15 +4608,14 @@
         </p:nvPicPr>
         <p:blipFill>
           <a:blip r:embed="rId3"/>
-          <a:srcRect l="705" t="7636" r="705"/>
           <a:stretch>
             <a:fillRect/>
           </a:stretch>
         </p:blipFill>
         <p:spPr>
           <a:xfrm>
-            <a:off x="630157" y="1137168"/>
-            <a:ext cx="10931685" cy="5720832"/>
+            <a:off x="198427" y="1491240"/>
+            <a:ext cx="11795146" cy="4729853"/>
           </a:xfrm>
           <a:prstGeom prst="rect">
             <a:avLst/>

</xml_diff>